<commit_message>
Walking shoe weight: 257g per shoe at 270mm in detail plan
Co-Authored-By: Claude Opus 5.5 <noreply@anthropic.com>
Claude-Session: https://claude.ai/code/session_01WbwBaiEPCZ7zKuMjGg7vqH
</commit_message>
<xml_diff>
--- a/launch/rs/design/detail-walking/rs-walking-detail-plan.pptx
+++ b/launch/rs/design/detail-walking/rs-walking-detail-plan.pptx
@@ -144,7 +144,7 @@
   <p:extLst>
     <p:ext uri="{521415D9-36F7-43E2-AB2F-B90AF26B5E84}">
       <p14:sectionLst xmlns:p14="http://schemas.microsoft.com/office/powerpoint/2010/main">
-        <p14:section name="개요" id="{4d885cc5-7974-801d-88ba-325f9c249ff1}">
+        <p14:section name="개요" id="{e5098482-5f7c-99bf-ca9c-869e5872bb71}">
           <p14:sldIdLst>
             <p14:sldId id="256"/>
             <p14:sldId id="257"/>
@@ -154,7 +154,7 @@
             <p14:sldId id="261"/>
           </p14:sldIdLst>
         </p14:section>
-        <p14:section name="1막 후킹" id="{1dc0bc3b-34d7-adc5-9e7e-a83035375644}">
+        <p14:section name="1막 후킹" id="{4ff23952-41cc-ba88-0dbd-f1e168b6851f}">
           <p14:sldIdLst>
             <p14:sldId id="262"/>
             <p14:sldId id="263"/>
@@ -164,7 +164,7 @@
             <p14:sldId id="267"/>
           </p14:sldIdLst>
         </p14:section>
-        <p14:section name="2막 안전" id="{e4d1f489-5866-e70c-95b9-6019d0bdef4c}">
+        <p14:section name="2막 안전" id="{813d8e23-944a-6e19-6a71-099809933d29}">
           <p14:sldIdLst>
             <p14:sldId id="268"/>
             <p14:sldId id="269"/>
@@ -173,7 +173,7 @@
             <p14:sldId id="272"/>
           </p14:sldIdLst>
         </p14:section>
-        <p14:section name="3막 편안" id="{5f144858-9fe7-0ec4-8f8d-1fa7c71d09d9}">
+        <p14:section name="3막 편안" id="{5a9de6fe-9f86-8e42-a1db-b1668e2dd7ff}">
           <p14:sldIdLst>
             <p14:sldId id="273"/>
             <p14:sldId id="274"/>
@@ -183,7 +183,7 @@
             <p14:sldId id="278"/>
           </p14:sldIdLst>
         </p14:section>
-        <p14:section name="4막 신뢰·구매" id="{0b1ee61a-3624-7bec-8719-9b6fca18233e}">
+        <p14:section name="4막 신뢰·구매" id="{5acab26d-70af-b708-bad7-a291b91be7e7}">
           <p14:sldIdLst>
             <p14:sldId id="279"/>
             <p14:sldId id="280"/>
@@ -198,7 +198,7 @@
             <p14:sldId id="289"/>
           </p14:sldIdLst>
         </p14:section>
-        <p14:section name="실행" id="{a9e58d06-9967-c5e2-4ae1-4060cc3f5fe0}">
+        <p14:section name="실행" id="{33998267-719a-47c1-4f7e-5b7f6fcb67c6}">
           <p14:sldIdLst>
             <p14:sldId id="290"/>
             <p14:sldId id="291"/>
@@ -15648,7 +15648,7 @@
                 <a:ea typeface="Malgun Gothic" pitchFamily="34" charset="-122"/>
                 <a:cs typeface="Malgun Gothic" pitchFamily="34" charset="-120"/>
               </a:rPr>
-              <a:t>[000] g</a:t>
+              <a:t>257 g</a:t>
             </a:r>
             <a:endParaRPr lang="en-US" sz="2600" dirty="0"/>
           </a:p>
@@ -15868,7 +15868,7 @@
                 <a:ea typeface="Malgun Gothic" pitchFamily="34" charset="-122"/>
                 <a:cs typeface="Malgun Gothic" pitchFamily="34" charset="-120"/>
               </a:rPr>
-              <a:t>한쪽 [000]g</a:t>
+              <a:t>한쪽 257g</a:t>
             </a:r>
             <a:endParaRPr lang="en-US" sz="1600" dirty="0"/>
           </a:p>
@@ -15890,6 +15890,35 @@
               </a:rPr>
               <a:t> </a:t>
             </a:r>
+            <a:endParaRPr lang="en-US" sz="1600" dirty="0"/>
+          </a:p>
+          <a:p>
+            <a:pPr algn="ctr" indent="0" marL="0">
+              <a:lnSpc>
+                <a:spcPct val="125000"/>
+              </a:lnSpc>
+              <a:buNone/>
+            </a:pPr>
+            <a:r>
+              <a:rPr lang="en-US" sz="1400" dirty="0">
+                <a:solidFill>
+                  <a:srgbClr val="232323"/>
+                </a:solidFill>
+                <a:latin typeface="Malgun Gothic" pitchFamily="34" charset="0"/>
+                <a:ea typeface="Malgun Gothic" pitchFamily="34" charset="-122"/>
+                <a:cs typeface="Malgun Gothic" pitchFamily="34" charset="-120"/>
+              </a:rPr>
+              <a:t>(270mm 기준)</a:t>
+            </a:r>
+            <a:endParaRPr lang="en-US" sz="1600" dirty="0"/>
+          </a:p>
+          <a:p>
+            <a:pPr algn="ctr" indent="0" marL="0">
+              <a:lnSpc>
+                <a:spcPct val="125000"/>
+              </a:lnSpc>
+              <a:buNone/>
+            </a:pPr>
             <a:endParaRPr lang="en-US" sz="1600" dirty="0"/>
           </a:p>
           <a:p>
@@ -36293,7 +36322,7 @@
                 <a:ea typeface="Malgun Gothic" pitchFamily="34" charset="-122"/>
                 <a:cs typeface="Malgun Gothic" pitchFamily="34" charset="-120"/>
               </a:rPr>
-              <a:t>사이즈 230~280 · 무게 [000]g</a:t>
+              <a:t>사이즈 230~280 · 무게 257g(270mm)</a:t>
             </a:r>
             <a:endParaRPr lang="en-US" sz="700" dirty="0"/>
           </a:p>
@@ -39878,7 +39907,7 @@
                           <a:ea typeface="Malgun Gothic" pitchFamily="34" charset="-122"/>
                           <a:cs typeface="Malgun Gothic" pitchFamily="34" charset="-120"/>
                         </a:rPr>
-                        <a:t>무게 실측 · C09 후</a:t>
+                        <a:t>270mm 257g 실측 · C09 후</a:t>
                       </a:r>
                       <a:endParaRPr lang="en-US" sz="1200" dirty="0">
                         <a:latin typeface="Malgun Gothic" charset="0"/>
@@ -42514,7 +42543,7 @@
                           <a:ea typeface="Malgun Gothic" pitchFamily="34" charset="-122"/>
                           <a:cs typeface="Malgun Gothic" pitchFamily="34" charset="-120"/>
                         </a:rPr>
-                        <a:t>무게 실측 (230mm 한쪽 + 사이즈별)</a:t>
+                        <a:t>무게 실측 ✅ 270mm 한쪽 257g (10/09) · 230mm 값 추후</a:t>
                       </a:r>
                       <a:endParaRPr lang="en-US" sz="1200" dirty="0">
                         <a:latin typeface="Malgun Gothic" charset="0"/>
@@ -42650,7 +42679,7 @@
                           <a:ea typeface="Malgun Gothic" pitchFamily="34" charset="-122"/>
                           <a:cs typeface="Malgun Gothic" pitchFamily="34" charset="-120"/>
                         </a:rPr>
-                        <a:t>공장 확인</a:t>
+                        <a:t>1차 확보</a:t>
                       </a:r>
                       <a:endParaRPr lang="en-US" sz="1200" dirty="0">
                         <a:latin typeface="Malgun Gothic" charset="0"/>
@@ -42718,7 +42747,7 @@
                           <a:ea typeface="Malgun Gothic" pitchFamily="34" charset="-122"/>
                           <a:cs typeface="Malgun Gothic" pitchFamily="34" charset="-120"/>
                         </a:rPr>
-                        <a:t>숫자 자리 비우지 말고 CUT 보류</a:t>
+                        <a:t>사이즈 표기 없이 숫자만 쓰지 않기</a:t>
                       </a:r>
                       <a:endParaRPr lang="en-US" sz="1200" dirty="0">
                         <a:latin typeface="Malgun Gothic" charset="0"/>
@@ -45148,7 +45177,7 @@
                           <a:ea typeface="Malgun Gothic" pitchFamily="34" charset="-122"/>
                           <a:cs typeface="Malgun Gothic" pitchFamily="34" charset="-120"/>
                         </a:rPr>
-                        <a:t>한쪽 [000]g · '하루 1만 보면 신발도 1만 번 든다'</a:t>
+                        <a:t>한쪽 257g(270mm) · '하루 1만 보면 신발도 1만 번 든다'</a:t>
                       </a:r>
                       <a:endParaRPr lang="en-US" sz="1300" dirty="0">
                         <a:latin typeface="Malgun Gothic" charset="0"/>
@@ -46486,7 +46515,7 @@
                 <a:ea typeface="Malgun Gothic" pitchFamily="34" charset="-122"/>
                 <a:cs typeface="Malgun Gothic" pitchFamily="34" charset="-120"/>
               </a:rPr>
-              <a:t>무게 실측 · 발볼 사양(P16) · 사이즈 체계(P03) · 패드 박리(P10)</a:t>
+              <a:t>발볼 사양(P16) · 사이즈 체계(P03) · 패드 박리(P10)</a:t>
             </a:r>
             <a:endParaRPr lang="en-US" sz="1500" dirty="0"/>
           </a:p>
@@ -47444,7 +47473,7 @@
                 <a:ea typeface="Malgun Gothic" pitchFamily="34" charset="-122"/>
                 <a:cs typeface="Malgun Gothic" pitchFamily="34" charset="-120"/>
               </a:rPr>
-              <a:t>한쪽 [000]g</a:t>
+              <a:t>한쪽 257g (270mm)</a:t>
             </a:r>
             <a:endParaRPr lang="en-US" sz="1500" dirty="0"/>
           </a:p>
@@ -47522,7 +47551,7 @@
                 <a:ea typeface="Malgun Gothic" pitchFamily="34" charset="-122"/>
                 <a:cs typeface="Malgun Gothic" pitchFamily="34" charset="-120"/>
               </a:rPr>
-              <a:t>증거: 무게 실측 (230mm 한쪽)</a:t>
+              <a:t>증거: 실측 완료 · 230mm 값은 추후 교체</a:t>
             </a:r>
             <a:endParaRPr lang="en-US" sz="1100" dirty="0"/>
           </a:p>

</xml_diff>